<commit_message>
add sampling optimization preprint
</commit_message>
<xml_diff>
--- a/pictures.pptx
+++ b/pictures.pptx
@@ -306,7 +306,7 @@
           <a:p>
             <a:fld id="{65BDA79E-ECE0-4F78-BA93-E393AD04CE65}" type="datetimeFigureOut">
               <a:rPr lang="fr-CA" smtClean="0"/>
-              <a:t>2025-11-17</a:t>
+              <a:t>2025-12-16</a:t>
             </a:fld>
             <a:endParaRPr lang="fr-CA"/>
           </a:p>
@@ -476,7 +476,7 @@
           <a:p>
             <a:fld id="{65BDA79E-ECE0-4F78-BA93-E393AD04CE65}" type="datetimeFigureOut">
               <a:rPr lang="fr-CA" smtClean="0"/>
-              <a:t>2025-11-17</a:t>
+              <a:t>2025-12-16</a:t>
             </a:fld>
             <a:endParaRPr lang="fr-CA"/>
           </a:p>
@@ -656,7 +656,7 @@
           <a:p>
             <a:fld id="{65BDA79E-ECE0-4F78-BA93-E393AD04CE65}" type="datetimeFigureOut">
               <a:rPr lang="fr-CA" smtClean="0"/>
-              <a:t>2025-11-17</a:t>
+              <a:t>2025-12-16</a:t>
             </a:fld>
             <a:endParaRPr lang="fr-CA"/>
           </a:p>
@@ -826,7 +826,7 @@
           <a:p>
             <a:fld id="{65BDA79E-ECE0-4F78-BA93-E393AD04CE65}" type="datetimeFigureOut">
               <a:rPr lang="fr-CA" smtClean="0"/>
-              <a:t>2025-11-17</a:t>
+              <a:t>2025-12-16</a:t>
             </a:fld>
             <a:endParaRPr lang="fr-CA"/>
           </a:p>
@@ -1072,7 +1072,7 @@
           <a:p>
             <a:fld id="{65BDA79E-ECE0-4F78-BA93-E393AD04CE65}" type="datetimeFigureOut">
               <a:rPr lang="fr-CA" smtClean="0"/>
-              <a:t>2025-11-17</a:t>
+              <a:t>2025-12-16</a:t>
             </a:fld>
             <a:endParaRPr lang="fr-CA"/>
           </a:p>
@@ -1304,7 +1304,7 @@
           <a:p>
             <a:fld id="{65BDA79E-ECE0-4F78-BA93-E393AD04CE65}" type="datetimeFigureOut">
               <a:rPr lang="fr-CA" smtClean="0"/>
-              <a:t>2025-11-17</a:t>
+              <a:t>2025-12-16</a:t>
             </a:fld>
             <a:endParaRPr lang="fr-CA"/>
           </a:p>
@@ -1671,7 +1671,7 @@
           <a:p>
             <a:fld id="{65BDA79E-ECE0-4F78-BA93-E393AD04CE65}" type="datetimeFigureOut">
               <a:rPr lang="fr-CA" smtClean="0"/>
-              <a:t>2025-11-17</a:t>
+              <a:t>2025-12-16</a:t>
             </a:fld>
             <a:endParaRPr lang="fr-CA"/>
           </a:p>
@@ -1789,7 +1789,7 @@
           <a:p>
             <a:fld id="{65BDA79E-ECE0-4F78-BA93-E393AD04CE65}" type="datetimeFigureOut">
               <a:rPr lang="fr-CA" smtClean="0"/>
-              <a:t>2025-11-17</a:t>
+              <a:t>2025-12-16</a:t>
             </a:fld>
             <a:endParaRPr lang="fr-CA"/>
           </a:p>
@@ -1884,7 +1884,7 @@
           <a:p>
             <a:fld id="{65BDA79E-ECE0-4F78-BA93-E393AD04CE65}" type="datetimeFigureOut">
               <a:rPr lang="fr-CA" smtClean="0"/>
-              <a:t>2025-11-17</a:t>
+              <a:t>2025-12-16</a:t>
             </a:fld>
             <a:endParaRPr lang="fr-CA"/>
           </a:p>
@@ -2161,7 +2161,7 @@
           <a:p>
             <a:fld id="{65BDA79E-ECE0-4F78-BA93-E393AD04CE65}" type="datetimeFigureOut">
               <a:rPr lang="fr-CA" smtClean="0"/>
-              <a:t>2025-11-17</a:t>
+              <a:t>2025-12-16</a:t>
             </a:fld>
             <a:endParaRPr lang="fr-CA"/>
           </a:p>
@@ -2418,7 +2418,7 @@
           <a:p>
             <a:fld id="{65BDA79E-ECE0-4F78-BA93-E393AD04CE65}" type="datetimeFigureOut">
               <a:rPr lang="fr-CA" smtClean="0"/>
-              <a:t>2025-11-17</a:t>
+              <a:t>2025-12-16</a:t>
             </a:fld>
             <a:endParaRPr lang="fr-CA"/>
           </a:p>
@@ -2631,7 +2631,7 @@
           <a:p>
             <a:fld id="{65BDA79E-ECE0-4F78-BA93-E393AD04CE65}" type="datetimeFigureOut">
               <a:rPr lang="fr-CA" smtClean="0"/>
-              <a:t>2025-11-17</a:t>
+              <a:t>2025-12-16</a:t>
             </a:fld>
             <a:endParaRPr lang="fr-CA"/>
           </a:p>
@@ -3394,38 +3394,6 @@
           </a:prstGeom>
         </p:spPr>
       </p:pic>
-      <p:pic>
-        <p:nvPicPr>
-          <p:cNvPr id="3" name="Image 2">
-            <a:extLst>
-              <a:ext uri="{FF2B5EF4-FFF2-40B4-BE49-F238E27FC236}">
-                <a16:creationId xmlns:a16="http://schemas.microsoft.com/office/drawing/2014/main" id="{955F2CD0-006A-D60C-FBBC-33AE9B4106C8}"/>
-              </a:ext>
-            </a:extLst>
-          </p:cNvPr>
-          <p:cNvPicPr>
-            <a:picLocks noChangeAspect="1"/>
-          </p:cNvPicPr>
-          <p:nvPr/>
-        </p:nvPicPr>
-        <p:blipFill>
-          <a:blip r:embed="rId3"/>
-          <a:stretch>
-            <a:fillRect/>
-          </a:stretch>
-        </p:blipFill>
-        <p:spPr>
-          <a:xfrm>
-            <a:off x="2286206" y="1409809"/>
-            <a:ext cx="7619588" cy="4038382"/>
-          </a:xfrm>
-          <a:prstGeom prst="roundRect">
-            <a:avLst>
-              <a:gd name="adj" fmla="val 7618"/>
-            </a:avLst>
-          </a:prstGeom>
-        </p:spPr>
-      </p:pic>
     </p:spTree>
     <p:extLst>
       <p:ext uri="{BB962C8B-B14F-4D97-AF65-F5344CB8AC3E}">

</xml_diff>